<commit_message>
feat: Add Tay chatbot (Claude API), proposal restructure & supporting docs
- Tay chatbot: Express proxy server with Claude Sonnet API, section-aware
  context, conversation history, concise response tuning
- Interactive Pitch: new Section 02 (Operating Paradigm), updated suggestions
  per section, larger chat panel, removed date references from CTAs
- New files: Team Roles, Tech Lead Profile, Full Pitch EDITABLE DOCX,
  INTAKE/Full Pitch DOCX generators, Transformation Roadmap XLSX
- Updated bibliography, Strategic Pitch (HTML/DOCX/PPTX), .gitignore (.env)

Co-Authored-By: Claude Opus 4.6 <noreply@anthropic.com>
</commit_message>
<xml_diff>
--- a/Taylor Group/proposal-2.0/pitch/Taylor-Group-Strategic-Pitch.pptx
+++ b/Taylor Group/proposal-2.0/pitch/Taylor-Group-Strategic-Pitch.pptx
@@ -6014,7 +6014,7 @@
                 <a:ea typeface="Calibri" pitchFamily="34" charset="-122"/>
                 <a:cs typeface="Calibri" pitchFamily="34" charset="-120"/>
               </a:rPr>
-              <a:t>APR</a:t>
+              <a:t>MAY</a:t>
             </a:r>
             <a:endParaRPr lang="en-US" sz="700" dirty="0"/>
           </a:p>
@@ -6053,7 +6053,7 @@
                 <a:ea typeface="Calibri" pitchFamily="34" charset="-122"/>
                 <a:cs typeface="Calibri" pitchFamily="34" charset="-120"/>
               </a:rPr>
-              <a:t>MAY</a:t>
+              <a:t>JUN</a:t>
             </a:r>
             <a:endParaRPr lang="en-US" sz="700" dirty="0"/>
           </a:p>
@@ -6092,7 +6092,7 @@
                 <a:ea typeface="Calibri" pitchFamily="34" charset="-122"/>
                 <a:cs typeface="Calibri" pitchFamily="34" charset="-120"/>
               </a:rPr>
-              <a:t>JUN</a:t>
+              <a:t>JUL</a:t>
             </a:r>
             <a:endParaRPr lang="en-US" sz="700" dirty="0"/>
           </a:p>
@@ -6131,7 +6131,7 @@
                 <a:ea typeface="Calibri" pitchFamily="34" charset="-122"/>
                 <a:cs typeface="Calibri" pitchFamily="34" charset="-120"/>
               </a:rPr>
-              <a:t>JUL</a:t>
+              <a:t>AUG</a:t>
             </a:r>
             <a:endParaRPr lang="en-US" sz="700" dirty="0"/>
           </a:p>
@@ -6170,7 +6170,7 @@
                 <a:ea typeface="Calibri" pitchFamily="34" charset="-122"/>
                 <a:cs typeface="Calibri" pitchFamily="34" charset="-120"/>
               </a:rPr>
-              <a:t>AUG</a:t>
+              <a:t>SEP</a:t>
             </a:r>
             <a:endParaRPr lang="en-US" sz="700" dirty="0"/>
           </a:p>
@@ -6209,7 +6209,7 @@
                 <a:ea typeface="Calibri" pitchFamily="34" charset="-122"/>
                 <a:cs typeface="Calibri" pitchFamily="34" charset="-120"/>
               </a:rPr>
-              <a:t>SEP</a:t>
+              <a:t>OCT</a:t>
             </a:r>
             <a:endParaRPr lang="en-US" sz="700" dirty="0"/>
           </a:p>
@@ -6248,7 +6248,7 @@
                 <a:ea typeface="Calibri" pitchFamily="34" charset="-122"/>
                 <a:cs typeface="Calibri" pitchFamily="34" charset="-120"/>
               </a:rPr>
-              <a:t>OCT</a:t>
+              <a:t>NOV</a:t>
             </a:r>
             <a:endParaRPr lang="en-US" sz="700" dirty="0"/>
           </a:p>
@@ -6287,7 +6287,7 @@
                 <a:ea typeface="Calibri" pitchFamily="34" charset="-122"/>
                 <a:cs typeface="Calibri" pitchFamily="34" charset="-120"/>
               </a:rPr>
-              <a:t>NOV</a:t>
+              <a:t>DEC</a:t>
             </a:r>
             <a:endParaRPr lang="en-US" sz="700" dirty="0"/>
           </a:p>
@@ -6326,7 +6326,7 @@
                 <a:ea typeface="Calibri" pitchFamily="34" charset="-122"/>
                 <a:cs typeface="Calibri" pitchFamily="34" charset="-120"/>
               </a:rPr>
-              <a:t>DEC</a:t>
+              <a:t>JAN+</a:t>
             </a:r>
             <a:endParaRPr lang="en-US" sz="700" dirty="0"/>
           </a:p>
@@ -6579,7 +6579,7 @@
         <p:spPr>
           <a:xfrm>
             <a:off x="3163824" y="2441448"/>
-            <a:ext cx="804672" cy="365760"/>
+            <a:ext cx="1609344" cy="365760"/>
           </a:xfrm>
           <a:prstGeom prst="rect">
             <a:avLst/>
@@ -6599,7 +6599,7 @@
         <p:spPr>
           <a:xfrm>
             <a:off x="3255264" y="2441448"/>
-            <a:ext cx="621792" cy="365760"/>
+            <a:ext cx="1426464" cy="365760"/>
           </a:xfrm>
           <a:prstGeom prst="rect">
             <a:avLst/>
@@ -6715,7 +6715,7 @@
         </p:nvSpPr>
         <p:spPr>
           <a:xfrm>
-            <a:off x="3968496" y="3035808"/>
+            <a:off x="4773168" y="3035808"/>
             <a:ext cx="3218688" cy="365760"/>
           </a:xfrm>
           <a:prstGeom prst="rect">
@@ -6735,7 +6735,7 @@
         </p:nvSpPr>
         <p:spPr>
           <a:xfrm>
-            <a:off x="4059936" y="3035808"/>
+            <a:off x="4864608" y="3035808"/>
             <a:ext cx="3035808" cy="365760"/>
           </a:xfrm>
           <a:prstGeom prst="rect">
@@ -6852,8 +6852,8 @@
         </p:nvSpPr>
         <p:spPr>
           <a:xfrm>
-            <a:off x="7187184" y="3630168"/>
-            <a:ext cx="1609344" cy="365760"/>
+            <a:off x="7991856" y="3630168"/>
+            <a:ext cx="804672" cy="365760"/>
           </a:xfrm>
           <a:prstGeom prst="rect">
             <a:avLst/>
@@ -6872,8 +6872,8 @@
         </p:nvSpPr>
         <p:spPr>
           <a:xfrm>
-            <a:off x="7278624" y="3630168"/>
-            <a:ext cx="1426464" cy="365760"/>
+            <a:off x="8083296" y="3630168"/>
+            <a:ext cx="621792" cy="365760"/>
           </a:xfrm>
           <a:prstGeom prst="rect">
             <a:avLst/>
@@ -8397,7 +8397,7 @@
                 <a:ea typeface="Calibri" pitchFamily="34" charset="-122"/>
                 <a:cs typeface="Calibri" pitchFamily="34" charset="-120"/>
               </a:rPr>
-              <a:t>Apr – May</a:t>
+              <a:t>May – Jun</a:t>
             </a:r>
             <a:endParaRPr lang="en-US" sz="800" dirty="0"/>
           </a:p>
@@ -8595,7 +8595,7 @@
                 <a:ea typeface="Calibri" pitchFamily="34" charset="-122"/>
                 <a:cs typeface="Calibri" pitchFamily="34" charset="-120"/>
               </a:rPr>
-              <a:t>Jun</a:t>
+              <a:t>Jul – Aug</a:t>
             </a:r>
             <a:endParaRPr lang="en-US" sz="800" dirty="0"/>
           </a:p>
@@ -8793,7 +8793,7 @@
                 <a:ea typeface="Calibri" pitchFamily="34" charset="-122"/>
                 <a:cs typeface="Calibri" pitchFamily="34" charset="-120"/>
               </a:rPr>
-              <a:t>Jul – Oct</a:t>
+              <a:t>Sep – Dec</a:t>
             </a:r>
             <a:endParaRPr lang="en-US" sz="800" dirty="0"/>
           </a:p>
@@ -8980,7 +8980,7 @@
                 <a:ea typeface="Calibri" pitchFamily="34" charset="-122"/>
                 <a:cs typeface="Calibri" pitchFamily="34" charset="-120"/>
               </a:rPr>
-              <a:t>Nov+</a:t>
+              <a:t>Jan 2027+</a:t>
             </a:r>
             <a:endParaRPr lang="en-US" sz="800" dirty="0"/>
           </a:p>
@@ -9148,7 +9148,7 @@
                 <a:ea typeface="Calibri" pitchFamily="34" charset="-122"/>
                 <a:cs typeface="Calibri" pitchFamily="34" charset="-120"/>
               </a:rPr>
-              <a:t>Start with INTAKE in April 2026. Contained, fixed-fee engagement. No obligation to proceed further.</a:t>
+              <a:t>Start with INTAKE in May 2026. Contained, fixed-fee engagement. No obligation to proceed further.</a:t>
             </a:r>
             <a:endParaRPr lang="en-US" sz="1100" dirty="0"/>
           </a:p>

</xml_diff>